<commit_message>
docs(presentation): align executive deck to PRODUCT_TRUTH.md + rebuild PPTX/PDF
Reframe the deck from the legacy 'Advertising Operating System' / document-knowledge
/ 'Digital Employees' framing to the code truth: Enterprise AI Operating System for
Advertising; AI-assisted human-approved drafting pipeline (never launches live ads);
Company Brain = marketing-performance memory. Fixed generator subtitle/footers and
the Digital-Employees, Company-Brain, knowledge-loss, pipeline, and use-case slides
(EN+TR), then regenerated the PPTX and PDF from the aligned source. Added
PRESENTATION_VALIDATION_REPORT.md (PASS). No app code/packages/domains/tests touched.

Co-Authored-By: Claude Opus 4.8 <noreply@anthropic.com>
</commit_message>
<xml_diff>
--- a/presentation/AdOS_Executive_Presentation.pptx
+++ b/presentation/AdOS_Executive_Presentation.pptx
@@ -3277,7 +3277,7 @@
                 </a:solidFill>
                 <a:latin typeface="Arial"/>
               </a:rPr>
-              <a:t>The Advertising Operating System</a:t>
+              <a:t>Enterprise AI Operating System for Advertising</a:t>
             </a:r>
           </a:p>
           <a:p>
@@ -3289,7 +3289,7 @@
                 </a:solidFill>
                 <a:latin typeface="Arial"/>
               </a:rPr>
-              <a:t>Reklam İşletim Sistemi</a:t>
+              <a:t>Reklam için Kurumsal Yapay Zekâ İşletim Sistemi</a:t>
             </a:r>
           </a:p>
         </p:txBody>
@@ -3546,7 +3546,7 @@
                 </a:solidFill>
                 <a:latin typeface="Arial"/>
               </a:rPr>
-              <a:t>AdOS — The Advertising Operating System</a:t>
+              <a:t>AdOS — Enterprise AI Operating System for Advertising</a:t>
             </a:r>
           </a:p>
         </p:txBody>
@@ -3581,7 +3581,7 @@
                 </a:solidFill>
                 <a:latin typeface="Arial"/>
               </a:rPr>
-              <a:t>The work gets done — you approve each step</a:t>
+              <a:t>The work gets drafted — you approve each step</a:t>
             </a:r>
           </a:p>
           <a:p>
@@ -3593,7 +3593,7 @@
                 </a:solidFill>
                 <a:latin typeface="Arial"/>
               </a:rPr>
-              <a:t>İş yapılır — her adımı siz onaylarsınız</a:t>
+              <a:t>İş taslaklanır — her adımı siz onaylarsınız</a:t>
             </a:r>
           </a:p>
         </p:txBody>
@@ -3628,7 +3628,7 @@
                 </a:solidFill>
                 <a:latin typeface="Arial"/>
               </a:rPr>
-              <a:t>AdOS moves work through clear stages, with a human decision at each gate. Autonomous, but never unaccountable.</a:t>
+              <a:t>AdOS drafts each campaign through clear stages, with a human decision at every gate. AI-assisted, never unaccountable — and never launched without you.</a:t>
             </a:r>
           </a:p>
         </p:txBody>
@@ -4393,7 +4393,7 @@
                 </a:solidFill>
                 <a:latin typeface="Arial"/>
               </a:rPr>
-              <a:t>AdOS — The Advertising Operating System</a:t>
+              <a:t>AdOS — Enterprise AI Operating System for Advertising</a:t>
             </a:r>
           </a:p>
         </p:txBody>
@@ -4428,7 +4428,7 @@
                 </a:solidFill>
                 <a:latin typeface="Arial"/>
               </a:rPr>
-              <a:t>The Company Brain: your living memory</a:t>
+              <a:t>The Company Brain: your marketing memory</a:t>
             </a:r>
           </a:p>
           <a:p>
@@ -4440,7 +4440,7 @@
                 </a:solidFill>
                 <a:latin typeface="Arial"/>
               </a:rPr>
-              <a:t>Şirket Beyni: yaşayan hafızanız</a:t>
+              <a:t>Şirket Beyni: pazarlama hafızanız</a:t>
             </a:r>
           </a:p>
         </p:txBody>
@@ -4475,7 +4475,7 @@
                 </a:solidFill>
                 <a:latin typeface="Arial"/>
               </a:rPr>
-              <a:t>Every document, decision and outcome becomes shared, searchable knowledge that grows more valuable over time — and never leaves your walls.</a:t>
+              <a:t>Every campaign, creative and result becomes shared, reusable knowledge — winning ads, channels and budgets — that grows more valuable over time and never leaves your walls.</a:t>
             </a:r>
           </a:p>
           <a:p>
@@ -4499,7 +4499,7 @@
                 </a:solidFill>
                 <a:latin typeface="Arial"/>
               </a:rPr>
-              <a:t>Her belge, karar ve sonuç; zamanla değerlenen, paylaşılan ve aranabilir bir bilgiye dönüşür — ve asla duvarlarınızdan çıkmaz.</a:t>
+              <a:t>Her kampanya, kreatif ve sonuç; paylaşılan ve yeniden kullanılabilir bir bilgiye dönüşür — kazanan reklamlar, kanallar ve bütçeler — zamanla değerlenir ve asla duvarlarınızdan çıkmaz.</a:t>
             </a:r>
           </a:p>
         </p:txBody>
@@ -4674,7 +4674,7 @@
                 </a:solidFill>
                 <a:latin typeface="Arial"/>
               </a:rPr>
-              <a:t>AdOS — The Advertising Operating System</a:t>
+              <a:t>AdOS — Enterprise AI Operating System for Advertising</a:t>
             </a:r>
           </a:p>
         </p:txBody>
@@ -4709,7 +4709,7 @@
                 </a:solidFill>
                 <a:latin typeface="Arial"/>
               </a:rPr>
-              <a:t>Digital Employees for every department</a:t>
+              <a:t>An AI-assisted stage at every step</a:t>
             </a:r>
           </a:p>
           <a:p>
@@ -4721,7 +4721,7 @@
                 </a:solidFill>
                 <a:latin typeface="Arial"/>
               </a:rPr>
-              <a:t>Her departman için Dijital Çalışanlar</a:t>
+              <a:t>Her adımda yapay zekâ destekli bir aşama</a:t>
             </a:r>
           </a:p>
         </p:txBody>
@@ -4756,7 +4756,7 @@
                 </a:solidFill>
                 <a:latin typeface="Arial"/>
               </a:rPr>
-              <a:t>Specialized assistants — HR, Finance, Quality, Maintenance and more — that know your policies and help your people, within clear limits.</a:t>
+              <a:t>Brief, creative, campaign draft, report — each stage drafted by local AI within your brand voice and rules, for a human to review and approve.</a:t>
             </a:r>
           </a:p>
           <a:p>
@@ -4780,7 +4780,7 @@
                 </a:solidFill>
                 <a:latin typeface="Arial"/>
               </a:rPr>
-              <a:t>Uzmanlaşmış asistanlar — İK, Finans, Kalite, Bakım ve daha fazlası — politikalarınızı bilen ve net sınırlar içinde yardım eden.</a:t>
+              <a:t>Özet, kreatif, kampanya taslağı, rapor — her aşama, marka sesiniz ve kurallarınız içinde yerel yapay zekâ tarafından taslaklanır; bir insan inceler ve onaylar.</a:t>
             </a:r>
           </a:p>
         </p:txBody>
@@ -4955,7 +4955,7 @@
                 </a:solidFill>
                 <a:latin typeface="Arial"/>
               </a:rPr>
-              <a:t>AdOS — The Advertising Operating System</a:t>
+              <a:t>AdOS — Enterprise AI Operating System for Advertising</a:t>
             </a:r>
           </a:p>
         </p:txBody>
@@ -5037,7 +5037,7 @@
                 </a:solidFill>
                 <a:latin typeface="Arial"/>
               </a:rPr>
-              <a:t>Run advertising campaigns. Answer policy questions instantly. Route approvals. Draft reports. Find the right document in seconds.</a:t>
+              <a:t>Draft advertising campaigns from an objective. Generate briefs, creative and budget plans. Route approvals. Draft performance reports. Reuse what worked.</a:t>
             </a:r>
           </a:p>
           <a:p>
@@ -5061,7 +5061,7 @@
                 </a:solidFill>
                 <a:latin typeface="Arial"/>
               </a:rPr>
-              <a:t>Reklam kampanyaları yürütün. Politika sorularını anında yanıtlayın. Onayları yönlendirin. Rapor hazırlayın. Doğru belgeyi saniyeler içinde bulun.</a:t>
+              <a:t>Bir hedeften reklam kampanyaları taslaklayın. Özet, kreatif ve bütçe planı üretin. Onayları yönlendirin. Performans raporları hazırlayın. İşe yarayanı yeniden kullanın.</a:t>
             </a:r>
           </a:p>
         </p:txBody>
@@ -5236,7 +5236,7 @@
                 </a:solidFill>
                 <a:latin typeface="Arial"/>
               </a:rPr>
-              <a:t>AdOS — The Advertising Operating System</a:t>
+              <a:t>AdOS — Enterprise AI Operating System for Advertising</a:t>
             </a:r>
           </a:p>
         </p:txBody>
@@ -5865,7 +5865,7 @@
                 </a:solidFill>
                 <a:latin typeface="Arial"/>
               </a:rPr>
-              <a:t>AdOS — The Advertising Operating System</a:t>
+              <a:t>AdOS — Enterprise AI Operating System for Advertising</a:t>
             </a:r>
           </a:p>
         </p:txBody>
@@ -6146,7 +6146,7 @@
                 </a:solidFill>
                 <a:latin typeface="Arial"/>
               </a:rPr>
-              <a:t>AdOS — The Advertising Operating System</a:t>
+              <a:t>AdOS — Enterprise AI Operating System for Advertising</a:t>
             </a:r>
           </a:p>
         </p:txBody>
@@ -6427,7 +6427,7 @@
                 </a:solidFill>
                 <a:latin typeface="Arial"/>
               </a:rPr>
-              <a:t>AdOS — The Advertising Operating System</a:t>
+              <a:t>AdOS — Enterprise AI Operating System for Advertising</a:t>
             </a:r>
           </a:p>
         </p:txBody>
@@ -6728,7 +6728,7 @@
                 </a:solidFill>
                 <a:latin typeface="Arial"/>
               </a:rPr>
-              <a:t>AdOS — The Advertising Operating System</a:t>
+              <a:t>AdOS — Enterprise AI Operating System for Advertising</a:t>
             </a:r>
           </a:p>
         </p:txBody>
@@ -7764,7 +7764,7 @@
                 </a:solidFill>
                 <a:latin typeface="Arial"/>
               </a:rPr>
-              <a:t>AdOS — The Advertising Operating System</a:t>
+              <a:t>AdOS — Enterprise AI Operating System for Advertising</a:t>
             </a:r>
           </a:p>
         </p:txBody>
@@ -8045,7 +8045,7 @@
                 </a:solidFill>
                 <a:latin typeface="Arial"/>
               </a:rPr>
-              <a:t>AdOS — The Advertising Operating System</a:t>
+              <a:t>AdOS — Enterprise AI Operating System for Advertising</a:t>
             </a:r>
           </a:p>
         </p:txBody>
@@ -8326,7 +8326,7 @@
                 </a:solidFill>
                 <a:latin typeface="Arial"/>
               </a:rPr>
-              <a:t>AdOS — The Advertising Operating System</a:t>
+              <a:t>AdOS — Enterprise AI Operating System for Advertising</a:t>
             </a:r>
           </a:p>
         </p:txBody>
@@ -8408,7 +8408,7 @@
                 </a:solidFill>
                 <a:latin typeface="Arial"/>
               </a:rPr>
-              <a:t>Modern AI for advertising and enterprise knowledge, running entirely on your infrastructure, under your control, with your data never leaving your building.</a:t>
+              <a:t>Modern AI for advertising, running entirely on your infrastructure, under your control, with your data never leaving your building.</a:t>
             </a:r>
           </a:p>
           <a:p>
@@ -8432,7 +8432,7 @@
                 </a:solidFill>
                 <a:latin typeface="Arial"/>
               </a:rPr>
-              <a:t>Reklam ve kurumsal bilgi için modern yapay zekâ; tamamen altyapınızda, kontrolünüzde çalışan, verileriniz binanızdan hiç çıkmadan.</a:t>
+              <a:t>Reklam için modern yapay zekâ; tamamen altyapınızda, kontrolünüzde çalışan, verileriniz binanızdan hiç çıkmadan.</a:t>
             </a:r>
           </a:p>
         </p:txBody>
@@ -8607,7 +8607,7 @@
                 </a:solidFill>
                 <a:latin typeface="Arial"/>
               </a:rPr>
-              <a:t>AdOS — The Advertising Operating System</a:t>
+              <a:t>AdOS — Enterprise AI Operating System for Advertising</a:t>
             </a:r>
           </a:p>
         </p:txBody>
@@ -9321,7 +9321,7 @@
                 </a:solidFill>
                 <a:latin typeface="Arial"/>
               </a:rPr>
-              <a:t>AdOS — The Advertising Operating System</a:t>
+              <a:t>AdOS — Enterprise AI Operating System for Advertising</a:t>
             </a:r>
           </a:p>
           <a:p>
@@ -9333,7 +9333,7 @@
                 </a:solidFill>
                 <a:latin typeface="Arial"/>
               </a:rPr>
-              <a:t>AdOS — Reklam İşletim Sistemi</a:t>
+              <a:t>AdOS — Reklam için Kurumsal Yapay Zekâ İşletim Sistemi</a:t>
             </a:r>
           </a:p>
         </p:txBody>
@@ -9590,7 +9590,7 @@
                 </a:solidFill>
                 <a:latin typeface="Arial"/>
               </a:rPr>
-              <a:t>AdOS — The Advertising Operating System</a:t>
+              <a:t>AdOS — Enterprise AI Operating System for Advertising</a:t>
             </a:r>
           </a:p>
         </p:txBody>
@@ -9871,7 +9871,7 @@
                 </a:solidFill>
                 <a:latin typeface="Arial"/>
               </a:rPr>
-              <a:t>AdOS — The Advertising Operating System</a:t>
+              <a:t>AdOS — Enterprise AI Operating System for Advertising</a:t>
             </a:r>
           </a:p>
         </p:txBody>
@@ -9906,7 +9906,7 @@
                 </a:solidFill>
                 <a:latin typeface="Arial"/>
               </a:rPr>
-              <a:t>Your most valuable asset walks out daily</a:t>
+              <a:t>What worked in your campaigns walks out the door</a:t>
             </a:r>
           </a:p>
           <a:p>
@@ -9918,7 +9918,7 @@
                 </a:solidFill>
                 <a:latin typeface="Arial"/>
               </a:rPr>
-              <a:t>En değerli varlığınız her gün çıkıyor</a:t>
+              <a:t>Kampanyalarınızda işe yarayan bilgi kapıdan çıkıyor</a:t>
             </a:r>
           </a:p>
         </p:txBody>
@@ -9953,7 +9953,7 @@
                 </a:solidFill>
                 <a:latin typeface="Arial"/>
               </a:rPr>
-              <a:t>Experience retires. Documents get lost. Every departure takes knowledge with it. What if your organization could remember everything it learned?</a:t>
+              <a:t>Experience retires. Winning playbooks get lost. Every departure takes campaign know-how with it. What if your team could remember every campaign that worked?</a:t>
             </a:r>
           </a:p>
           <a:p>
@@ -9977,7 +9977,7 @@
                 </a:solidFill>
                 <a:latin typeface="Arial"/>
               </a:rPr>
-              <a:t>Deneyim emekli oluyor. Belgeler kayboluyor. Her ayrılış bilgiyi götürüyor. Ya kurumunuz öğrendiği her şeyi hatırlayabilseydi?</a:t>
+              <a:t>Deneyim emekli oluyor. Kazanan taktikler kayboluyor. Her ayrılış kampanya bilgisini götürüyor. Ya ekibiniz işe yarayan her kampanyayı hatırlayabilseydi?</a:t>
             </a:r>
           </a:p>
         </p:txBody>
@@ -10152,7 +10152,7 @@
                 </a:solidFill>
                 <a:latin typeface="Arial"/>
               </a:rPr>
-              <a:t>AdOS — The Advertising Operating System</a:t>
+              <a:t>AdOS — Enterprise AI Operating System for Advertising</a:t>
             </a:r>
           </a:p>
         </p:txBody>
@@ -10433,7 +10433,7 @@
                 </a:solidFill>
                 <a:latin typeface="Arial"/>
               </a:rPr>
-              <a:t>AdOS — The Advertising Operating System</a:t>
+              <a:t>AdOS — Enterprise AI Operating System for Advertising</a:t>
             </a:r>
           </a:p>
         </p:txBody>
@@ -10714,7 +10714,7 @@
                 </a:solidFill>
                 <a:latin typeface="Arial"/>
               </a:rPr>
-              <a:t>AdOS — The Advertising Operating System</a:t>
+              <a:t>AdOS — Enterprise AI Operating System for Advertising</a:t>
             </a:r>
           </a:p>
         </p:txBody>
@@ -11400,7 +11400,7 @@
                 </a:solidFill>
                 <a:latin typeface="Arial"/>
               </a:rPr>
-              <a:t>AdOS — The Advertising Operating System</a:t>
+              <a:t>AdOS — Enterprise AI Operating System for Advertising</a:t>
             </a:r>
           </a:p>
         </p:txBody>
@@ -12086,7 +12086,7 @@
                 </a:solidFill>
                 <a:latin typeface="Arial"/>
               </a:rPr>
-              <a:t>AdOS — The Advertising Operating System</a:t>
+              <a:t>AdOS — Enterprise AI Operating System for Advertising</a:t>
             </a:r>
           </a:p>
         </p:txBody>

</xml_diff>